<commit_message>
feat: refresh skill pack content
</commit_message>
<xml_diff>
--- a/assets/theme-neutral.pptx
+++ b/assets/theme-neutral.pptx
@@ -1288,8 +1288,8 @@
         </p:nvSpPr>
         <p:spPr>
           <a:xfrm>
-            <a:off x="722313" y="4406900"/>
-            <a:ext cx="7772400" cy="1362075"/>
+            <a:off x="6355080" y="2651760"/>
+            <a:ext cx="5230368" cy="1188720"/>
           </a:xfrm>
         </p:spPr>
         <p:txBody>
@@ -1320,8 +1320,8 @@
         </p:nvSpPr>
         <p:spPr>
           <a:xfrm>
-            <a:off x="722313" y="2906713"/>
-            <a:ext cx="7772400" cy="1500187"/>
+            <a:off x="6355080" y="3931920"/>
+            <a:ext cx="5230368" cy="1097280"/>
           </a:xfrm>
         </p:spPr>
         <p:txBody>
@@ -1490,6 +1490,255 @@
             </a:fld>
             <a:endParaRPr lang="en-US"/>
           </a:p>
+        </p:txBody>
+      </p:sp>
+      <p:sp>
+        <p:nvSpPr>
+          <p:cNvPr id="9007" name="deco7"/>
+          <p:cNvSpPr/>
+          <p:nvPr/>
+        </p:nvSpPr>
+        <p:spPr>
+          <a:xfrm>
+            <a:off x="0" y="0"/>
+            <a:ext cx="3931920" cy="6858000"/>
+          </a:xfrm>
+          <a:prstGeom prst="rect">
+            <a:avLst/>
+          </a:prstGeom>
+          <a:solidFill>
+            <a:srgbClr val="006DB8">None</a:srgbClr>
+          </a:solidFill>
+          <a:ln>
+            <a:noFill/>
+          </a:ln>
+        </p:spPr>
+        <p:txBody>
+          <a:bodyPr/>
+          <a:lstStyle/>
+          <a:p/>
+        </p:txBody>
+      </p:sp>
+      <p:sp>
+        <p:nvSpPr>
+          <p:cNvPr id="9008" name="deco8"/>
+          <p:cNvSpPr/>
+          <p:nvPr/>
+        </p:nvSpPr>
+        <p:spPr>
+          <a:xfrm>
+            <a:off x="0" y="0"/>
+            <a:ext cx="50292" cy="6858000"/>
+          </a:xfrm>
+          <a:prstGeom prst="rect">
+            <a:avLst/>
+          </a:prstGeom>
+          <a:solidFill>
+            <a:srgbClr val="6096E6">None</a:srgbClr>
+          </a:solidFill>
+          <a:ln>
+            <a:noFill/>
+          </a:ln>
+        </p:spPr>
+        <p:txBody>
+          <a:bodyPr/>
+          <a:lstStyle/>
+          <a:p/>
+        </p:txBody>
+      </p:sp>
+      <p:sp>
+        <p:nvSpPr>
+          <p:cNvPr id="9009" name="deco9"/>
+          <p:cNvSpPr/>
+          <p:nvPr/>
+        </p:nvSpPr>
+        <p:spPr>
+          <a:xfrm>
+            <a:off x="960120" y="2834640"/>
+            <a:ext cx="2011680" cy="2011680"/>
+          </a:xfrm>
+          <a:prstGeom prst="diamond">
+            <a:avLst/>
+          </a:prstGeom>
+          <a:solidFill>
+            <a:srgbClr val="FFFFFF">
+              <a:alpha val="70000"/>
+            </a:srgbClr>
+          </a:solidFill>
+          <a:ln>
+            <a:noFill/>
+          </a:ln>
+        </p:spPr>
+        <p:txBody>
+          <a:bodyPr/>
+          <a:lstStyle/>
+          <a:p/>
+        </p:txBody>
+      </p:sp>
+      <p:sp>
+        <p:nvSpPr>
+          <p:cNvPr id="90010" name="deco10"/>
+          <p:cNvSpPr/>
+          <p:nvPr/>
+        </p:nvSpPr>
+        <p:spPr>
+          <a:xfrm>
+            <a:off x="1691640" y="3291840"/>
+            <a:ext cx="914400" cy="914400"/>
+          </a:xfrm>
+          <a:prstGeom prst="ellipse">
+            <a:avLst/>
+          </a:prstGeom>
+          <a:solidFill>
+            <a:srgbClr val="B39B77">
+              <a:alpha val="42000"/>
+            </a:srgbClr>
+          </a:solidFill>
+          <a:ln>
+            <a:noFill/>
+          </a:ln>
+        </p:spPr>
+        <p:txBody>
+          <a:bodyPr/>
+          <a:lstStyle/>
+          <a:p/>
+        </p:txBody>
+      </p:sp>
+      <p:sp>
+        <p:nvSpPr>
+          <p:cNvPr id="90011" name="deco11"/>
+          <p:cNvSpPr/>
+          <p:nvPr/>
+        </p:nvSpPr>
+        <p:spPr>
+          <a:xfrm>
+            <a:off x="4663440" y="2103120"/>
+            <a:ext cx="6611112" cy="22860"/>
+          </a:xfrm>
+          <a:prstGeom prst="rect">
+            <a:avLst/>
+          </a:prstGeom>
+          <a:solidFill>
+            <a:srgbClr val="6096E6">None</a:srgbClr>
+          </a:solidFill>
+          <a:ln>
+            <a:noFill/>
+          </a:ln>
+        </p:spPr>
+        <p:txBody>
+          <a:bodyPr/>
+          <a:lstStyle/>
+          <a:p/>
+        </p:txBody>
+      </p:sp>
+      <p:sp>
+        <p:nvSpPr>
+          <p:cNvPr id="90012" name="deco12"/>
+          <p:cNvSpPr/>
+          <p:nvPr/>
+        </p:nvSpPr>
+        <p:spPr>
+          <a:xfrm>
+            <a:off x="4663440" y="5760720"/>
+            <a:ext cx="6611112" cy="22860"/>
+          </a:xfrm>
+          <a:prstGeom prst="rect">
+            <a:avLst/>
+          </a:prstGeom>
+          <a:solidFill>
+            <a:srgbClr val="6096E6">None</a:srgbClr>
+          </a:solidFill>
+          <a:ln>
+            <a:noFill/>
+          </a:ln>
+        </p:spPr>
+        <p:txBody>
+          <a:bodyPr/>
+          <a:lstStyle/>
+          <a:p/>
+        </p:txBody>
+      </p:sp>
+      <p:sp>
+        <p:nvSpPr>
+          <p:cNvPr id="90013" name="deco13"/>
+          <p:cNvSpPr/>
+          <p:nvPr/>
+        </p:nvSpPr>
+        <p:spPr>
+          <a:xfrm>
+            <a:off x="10168128" y="548640"/>
+            <a:ext cx="1901952" cy="822960"/>
+          </a:xfrm>
+          <a:prstGeom prst="rect">
+            <a:avLst/>
+          </a:prstGeom>
+          <a:solidFill>
+            <a:srgbClr val="B39B77">None</a:srgbClr>
+          </a:solidFill>
+          <a:ln>
+            <a:noFill/>
+          </a:ln>
+        </p:spPr>
+        <p:txBody>
+          <a:bodyPr/>
+          <a:lstStyle/>
+          <a:p/>
+        </p:txBody>
+      </p:sp>
+      <p:sp>
+        <p:nvSpPr>
+          <p:cNvPr id="90014" name="deco14"/>
+          <p:cNvSpPr/>
+          <p:nvPr/>
+        </p:nvSpPr>
+        <p:spPr>
+          <a:xfrm>
+            <a:off x="10991088" y="758952"/>
+            <a:ext cx="402336" cy="402336"/>
+          </a:xfrm>
+          <a:prstGeom prst="diamond">
+            <a:avLst/>
+          </a:prstGeom>
+          <a:solidFill>
+            <a:srgbClr val="FFFFFF">None</a:srgbClr>
+          </a:solidFill>
+          <a:ln>
+            <a:noFill/>
+          </a:ln>
+        </p:spPr>
+        <p:txBody>
+          <a:bodyPr/>
+          <a:lstStyle/>
+          <a:p/>
+        </p:txBody>
+      </p:sp>
+      <p:sp>
+        <p:nvSpPr>
+          <p:cNvPr id="90015" name="deco15"/>
+          <p:cNvSpPr/>
+          <p:nvPr/>
+        </p:nvSpPr>
+        <p:spPr>
+          <a:xfrm>
+            <a:off x="10607040" y="758952"/>
+            <a:ext cx="219456" cy="402336"/>
+          </a:xfrm>
+          <a:prstGeom prst="diamond">
+            <a:avLst/>
+          </a:prstGeom>
+          <a:solidFill>
+            <a:srgbClr val="FFFFFF">
+              <a:alpha val="70000"/>
+            </a:srgbClr>
+          </a:solidFill>
+          <a:ln>
+            <a:noFill/>
+          </a:ln>
+        </p:spPr>
+        <p:txBody>
+          <a:bodyPr/>
+          <a:lstStyle/>
+          <a:p/>
         </p:txBody>
       </p:sp>
     </p:spTree>

</xml_diff>